<commit_message>
cambios ajuste P. ciencia de datos
</commit_message>
<xml_diff>
--- a/content/resources/clase-1/area-prog.pptx
+++ b/content/resources/clase-1/area-prog.pptx
@@ -107,6 +107,11 @@
       </a:defRPr>
     </a:lvl9pPr>
   </p:defaultTextStyle>
+  <p:extLst>
+    <p:ext uri="{EFAFB233-063F-42B5-8137-9DF3F51BA10A}">
+      <p15:sldGuideLst xmlns:p15="http://schemas.microsoft.com/office/powerpoint/2012/main"/>
+    </p:ext>
+  </p:extLst>
 </p:presentation>
 </file>
 
@@ -192,7 +197,7 @@
           <a:p>
             <a:fld id="{A8E638A4-396E-49A0-9798-6C3099080251}" type="datetimeFigureOut">
               <a:rPr lang="es-CO" smtClean="0"/>
-              <a:t>22/08/2023</a:t>
+              <a:t>2/09/26</a:t>
             </a:fld>
             <a:endParaRPr lang="es-CO"/>
           </a:p>
@@ -731,7 +736,7 @@
           <a:p>
             <a:fld id="{027B8169-753D-47FB-877B-A215314F11A5}" type="datetimeFigureOut">
               <a:rPr lang="es-CO" smtClean="0"/>
-              <a:t>22/08/2023</a:t>
+              <a:t>2/09/26</a:t>
             </a:fld>
             <a:endParaRPr lang="es-CO"/>
           </a:p>
@@ -931,7 +936,7 @@
           <a:p>
             <a:fld id="{027B8169-753D-47FB-877B-A215314F11A5}" type="datetimeFigureOut">
               <a:rPr lang="es-CO" smtClean="0"/>
-              <a:t>22/08/2023</a:t>
+              <a:t>2/09/26</a:t>
             </a:fld>
             <a:endParaRPr lang="es-CO"/>
           </a:p>
@@ -1141,7 +1146,7 @@
           <a:p>
             <a:fld id="{027B8169-753D-47FB-877B-A215314F11A5}" type="datetimeFigureOut">
               <a:rPr lang="es-CO" smtClean="0"/>
-              <a:t>22/08/2023</a:t>
+              <a:t>2/09/26</a:t>
             </a:fld>
             <a:endParaRPr lang="es-CO"/>
           </a:p>
@@ -2501,7 +2506,7 @@
           <a:p>
             <a:fld id="{027B8169-753D-47FB-877B-A215314F11A5}" type="datetimeFigureOut">
               <a:rPr lang="es-CO" smtClean="0"/>
-              <a:t>22/08/2023</a:t>
+              <a:t>2/09/26</a:t>
             </a:fld>
             <a:endParaRPr lang="es-CO"/>
           </a:p>
@@ -2777,7 +2782,7 @@
           <a:p>
             <a:fld id="{027B8169-753D-47FB-877B-A215314F11A5}" type="datetimeFigureOut">
               <a:rPr lang="es-CO" smtClean="0"/>
-              <a:t>22/08/2023</a:t>
+              <a:t>2/09/26</a:t>
             </a:fld>
             <a:endParaRPr lang="es-CO"/>
           </a:p>
@@ -3045,7 +3050,7 @@
           <a:p>
             <a:fld id="{027B8169-753D-47FB-877B-A215314F11A5}" type="datetimeFigureOut">
               <a:rPr lang="es-CO" smtClean="0"/>
-              <a:t>22/08/2023</a:t>
+              <a:t>2/09/26</a:t>
             </a:fld>
             <a:endParaRPr lang="es-CO"/>
           </a:p>
@@ -3460,7 +3465,7 @@
           <a:p>
             <a:fld id="{027B8169-753D-47FB-877B-A215314F11A5}" type="datetimeFigureOut">
               <a:rPr lang="es-CO" smtClean="0"/>
-              <a:t>22/08/2023</a:t>
+              <a:t>2/09/26</a:t>
             </a:fld>
             <a:endParaRPr lang="es-CO"/>
           </a:p>
@@ -3602,7 +3607,7 @@
           <a:p>
             <a:fld id="{027B8169-753D-47FB-877B-A215314F11A5}" type="datetimeFigureOut">
               <a:rPr lang="es-CO" smtClean="0"/>
-              <a:t>22/08/2023</a:t>
+              <a:t>2/09/26</a:t>
             </a:fld>
             <a:endParaRPr lang="es-CO"/>
           </a:p>
@@ -3715,7 +3720,7 @@
           <a:p>
             <a:fld id="{027B8169-753D-47FB-877B-A215314F11A5}" type="datetimeFigureOut">
               <a:rPr lang="es-CO" smtClean="0"/>
-              <a:t>22/08/2023</a:t>
+              <a:t>2/09/26</a:t>
             </a:fld>
             <a:endParaRPr lang="es-CO"/>
           </a:p>
@@ -4028,7 +4033,7 @@
           <a:p>
             <a:fld id="{027B8169-753D-47FB-877B-A215314F11A5}" type="datetimeFigureOut">
               <a:rPr lang="es-CO" smtClean="0"/>
-              <a:t>22/08/2023</a:t>
+              <a:t>2/09/26</a:t>
             </a:fld>
             <a:endParaRPr lang="es-CO"/>
           </a:p>
@@ -4317,7 +4322,7 @@
           <a:p>
             <a:fld id="{027B8169-753D-47FB-877B-A215314F11A5}" type="datetimeFigureOut">
               <a:rPr lang="es-CO" smtClean="0"/>
-              <a:t>22/08/2023</a:t>
+              <a:t>2/09/26</a:t>
             </a:fld>
             <a:endParaRPr lang="es-CO"/>
           </a:p>
@@ -4560,7 +4565,7 @@
           <a:p>
             <a:fld id="{027B8169-753D-47FB-877B-A215314F11A5}" type="datetimeFigureOut">
               <a:rPr lang="es-CO" smtClean="0"/>
-              <a:t>22/08/2023</a:t>
+              <a:t>2/09/26</a:t>
             </a:fld>
             <a:endParaRPr lang="es-CO"/>
           </a:p>
@@ -5510,40 +5515,6 @@
           </a:p>
         </p:txBody>
       </p:sp>
-      <p:pic>
-        <p:nvPicPr>
-          <p:cNvPr id="404" name="Google Shape;404;g1dc7d2207bd_1_0"/>
-          <p:cNvPicPr preferRelativeResize="0"/>
-          <p:nvPr/>
-        </p:nvPicPr>
-        <p:blipFill>
-          <a:blip r:embed="rId4">
-            <a:alphaModFix/>
-          </a:blip>
-          <a:stretch>
-            <a:fillRect/>
-          </a:stretch>
-        </p:blipFill>
-        <p:spPr>
-          <a:xfrm>
-            <a:off x="1017725" y="2210500"/>
-            <a:ext cx="10452100" cy="1803400"/>
-          </a:xfrm>
-          <a:prstGeom prst="rect">
-            <a:avLst/>
-          </a:prstGeom>
-          <a:noFill/>
-          <a:ln w="19050" cap="flat" cmpd="sng">
-            <a:solidFill>
-              <a:srgbClr val="434343"/>
-            </a:solidFill>
-            <a:prstDash val="solid"/>
-            <a:round/>
-            <a:headEnd type="none" w="sm" len="sm"/>
-            <a:tailEnd type="none" w="sm" len="sm"/>
-          </a:ln>
-        </p:spPr>
-      </p:pic>
       <p:sp>
         <p:nvSpPr>
           <p:cNvPr id="405" name="Google Shape;405;g1dc7d2207bd_1_0"/>
@@ -5604,801 +5575,6 @@
       </p:sp>
       <p:sp>
         <p:nvSpPr>
-          <p:cNvPr id="406" name="Google Shape;406;g1dc7d2207bd_1_0"/>
-          <p:cNvSpPr/>
-          <p:nvPr/>
-        </p:nvSpPr>
-        <p:spPr>
-          <a:xfrm>
-            <a:off x="1138000" y="4534167"/>
-            <a:ext cx="1922400" cy="545100"/>
-          </a:xfrm>
-          <a:prstGeom prst="homePlate">
-            <a:avLst>
-              <a:gd name="adj" fmla="val 50000"/>
-            </a:avLst>
-          </a:prstGeom>
-          <a:solidFill>
-            <a:schemeClr val="lt2"/>
-          </a:solidFill>
-          <a:ln w="9525" cap="flat" cmpd="sng">
-            <a:solidFill>
-              <a:schemeClr val="accent2"/>
-            </a:solidFill>
-            <a:prstDash val="solid"/>
-            <a:round/>
-            <a:headEnd type="none" w="sm" len="sm"/>
-            <a:tailEnd type="none" w="sm" len="sm"/>
-          </a:ln>
-        </p:spPr>
-        <p:txBody>
-          <a:bodyPr spcFirstLastPara="1" wrap="square" lIns="121900" tIns="121900" rIns="121900" bIns="121900" anchor="ctr" anchorCtr="0">
-            <a:noAutofit/>
-          </a:bodyPr>
-          <a:lstStyle/>
-          <a:p>
-            <a:pPr marL="0" marR="0" lvl="0" indent="0" algn="l" rtl="0">
-              <a:lnSpc>
-                <a:spcPct val="100000"/>
-              </a:lnSpc>
-              <a:spcBef>
-                <a:spcPct val="0"/>
-              </a:spcBef>
-              <a:spcAft>
-                <a:spcPct val="0"/>
-              </a:spcAft>
-              <a:buClr>
-                <a:srgbClr val="000000"/>
-              </a:buClr>
-              <a:buSzPts val="1900"/>
-              <a:buFont typeface="Arial"/>
-              <a:buNone/>
-            </a:pPr>
-            <a:r>
-              <a:rPr lang="en-US" sz="1900" b="1" i="0" u="none" strike="noStrike" cap="none">
-                <a:solidFill>
-                  <a:schemeClr val="accent2"/>
-                </a:solidFill>
-                <a:latin typeface="Abel"/>
-                <a:ea typeface="Abel"/>
-                <a:cs typeface="Abel"/>
-                <a:sym typeface="Abel"/>
-              </a:rPr>
-              <a:t>Programación I</a:t>
-            </a:r>
-            <a:endParaRPr sz="1900" b="1" i="0" u="none" strike="noStrike" cap="none">
-              <a:solidFill>
-                <a:schemeClr val="accent2"/>
-              </a:solidFill>
-              <a:latin typeface="Abel"/>
-              <a:ea typeface="Abel"/>
-              <a:cs typeface="Abel"/>
-              <a:sym typeface="Abel"/>
-            </a:endParaRPr>
-          </a:p>
-        </p:txBody>
-      </p:sp>
-      <p:sp>
-        <p:nvSpPr>
-          <p:cNvPr id="407" name="Google Shape;407;g1dc7d2207bd_1_0"/>
-          <p:cNvSpPr/>
-          <p:nvPr/>
-        </p:nvSpPr>
-        <p:spPr>
-          <a:xfrm>
-            <a:off x="3304467" y="4864133"/>
-            <a:ext cx="1922400" cy="545100"/>
-          </a:xfrm>
-          <a:prstGeom prst="homePlate">
-            <a:avLst>
-              <a:gd name="adj" fmla="val 50000"/>
-            </a:avLst>
-          </a:prstGeom>
-          <a:solidFill>
-            <a:schemeClr val="lt2"/>
-          </a:solidFill>
-          <a:ln w="9525" cap="flat" cmpd="sng">
-            <a:solidFill>
-              <a:schemeClr val="accent2"/>
-            </a:solidFill>
-            <a:prstDash val="solid"/>
-            <a:round/>
-            <a:headEnd type="none" w="sm" len="sm"/>
-            <a:tailEnd type="none" w="sm" len="sm"/>
-          </a:ln>
-        </p:spPr>
-        <p:txBody>
-          <a:bodyPr spcFirstLastPara="1" wrap="square" lIns="121900" tIns="121900" rIns="121900" bIns="121900" anchor="ctr" anchorCtr="0">
-            <a:noAutofit/>
-          </a:bodyPr>
-          <a:lstStyle/>
-          <a:p>
-            <a:pPr marL="0" marR="0" lvl="0" indent="0" algn="l" rtl="0">
-              <a:lnSpc>
-                <a:spcPct val="100000"/>
-              </a:lnSpc>
-              <a:spcBef>
-                <a:spcPct val="0"/>
-              </a:spcBef>
-              <a:spcAft>
-                <a:spcPct val="0"/>
-              </a:spcAft>
-              <a:buClr>
-                <a:srgbClr val="000000"/>
-              </a:buClr>
-              <a:buSzPts val="1900"/>
-              <a:buFont typeface="Arial"/>
-              <a:buNone/>
-            </a:pPr>
-            <a:r>
-              <a:rPr lang="en-US" sz="1900" b="1" i="0" u="none" strike="noStrike" cap="none">
-                <a:solidFill>
-                  <a:schemeClr val="accent2"/>
-                </a:solidFill>
-                <a:latin typeface="Abel"/>
-                <a:ea typeface="Abel"/>
-                <a:cs typeface="Abel"/>
-                <a:sym typeface="Abel"/>
-              </a:rPr>
-              <a:t>Programación II</a:t>
-            </a:r>
-            <a:endParaRPr sz="1900" b="1" i="0" u="none" strike="noStrike" cap="none">
-              <a:solidFill>
-                <a:schemeClr val="accent2"/>
-              </a:solidFill>
-              <a:latin typeface="Abel"/>
-              <a:ea typeface="Abel"/>
-              <a:cs typeface="Abel"/>
-              <a:sym typeface="Abel"/>
-            </a:endParaRPr>
-          </a:p>
-        </p:txBody>
-      </p:sp>
-      <p:sp>
-        <p:nvSpPr>
-          <p:cNvPr id="408" name="Google Shape;408;g1dc7d2207bd_1_0"/>
-          <p:cNvSpPr/>
-          <p:nvPr/>
-        </p:nvSpPr>
-        <p:spPr>
-          <a:xfrm>
-            <a:off x="1138000" y="5203650"/>
-            <a:ext cx="1922400" cy="545100"/>
-          </a:xfrm>
-          <a:prstGeom prst="homePlate">
-            <a:avLst>
-              <a:gd name="adj" fmla="val 50000"/>
-            </a:avLst>
-          </a:prstGeom>
-          <a:solidFill>
-            <a:schemeClr val="lt2"/>
-          </a:solidFill>
-          <a:ln w="9525" cap="flat" cmpd="sng">
-            <a:solidFill>
-              <a:srgbClr val="435D74"/>
-            </a:solidFill>
-            <a:prstDash val="solid"/>
-            <a:round/>
-            <a:headEnd type="none" w="sm" len="sm"/>
-            <a:tailEnd type="none" w="sm" len="sm"/>
-          </a:ln>
-        </p:spPr>
-        <p:txBody>
-          <a:bodyPr spcFirstLastPara="1" wrap="square" lIns="121900" tIns="121900" rIns="121900" bIns="121900" anchor="ctr" anchorCtr="0">
-            <a:noAutofit/>
-          </a:bodyPr>
-          <a:lstStyle/>
-          <a:p>
-            <a:pPr marL="0" marR="0" lvl="0" indent="0" algn="l" rtl="0">
-              <a:lnSpc>
-                <a:spcPct val="100000"/>
-              </a:lnSpc>
-              <a:spcBef>
-                <a:spcPct val="0"/>
-              </a:spcBef>
-              <a:spcAft>
-                <a:spcPct val="0"/>
-              </a:spcAft>
-              <a:buClr>
-                <a:srgbClr val="000000"/>
-              </a:buClr>
-              <a:buSzPts val="1900"/>
-              <a:buFont typeface="Arial"/>
-              <a:buNone/>
-            </a:pPr>
-            <a:r>
-              <a:rPr lang="en-US" sz="1900" b="1" i="0" u="none" strike="noStrike" cap="none">
-                <a:solidFill>
-                  <a:srgbClr val="435D74"/>
-                </a:solidFill>
-                <a:latin typeface="Abel"/>
-                <a:ea typeface="Abel"/>
-                <a:cs typeface="Abel"/>
-                <a:sym typeface="Abel"/>
-              </a:rPr>
-              <a:t>M. Fundamentales</a:t>
-            </a:r>
-            <a:endParaRPr sz="1900" b="1" i="0" u="none" strike="noStrike" cap="none">
-              <a:solidFill>
-                <a:srgbClr val="435D74"/>
-              </a:solidFill>
-              <a:latin typeface="Abel"/>
-              <a:ea typeface="Abel"/>
-              <a:cs typeface="Abel"/>
-              <a:sym typeface="Abel"/>
-            </a:endParaRPr>
-          </a:p>
-        </p:txBody>
-      </p:sp>
-      <p:sp>
-        <p:nvSpPr>
-          <p:cNvPr id="409" name="Google Shape;409;g1dc7d2207bd_1_0"/>
-          <p:cNvSpPr/>
-          <p:nvPr/>
-        </p:nvSpPr>
-        <p:spPr>
-          <a:xfrm>
-            <a:off x="5413533" y="5136767"/>
-            <a:ext cx="1922400" cy="545100"/>
-          </a:xfrm>
-          <a:prstGeom prst="homePlate">
-            <a:avLst>
-              <a:gd name="adj" fmla="val 50000"/>
-            </a:avLst>
-          </a:prstGeom>
-          <a:solidFill>
-            <a:schemeClr val="lt2"/>
-          </a:solidFill>
-          <a:ln w="9525" cap="flat" cmpd="sng">
-            <a:solidFill>
-              <a:schemeClr val="accent2"/>
-            </a:solidFill>
-            <a:prstDash val="solid"/>
-            <a:round/>
-            <a:headEnd type="none" w="sm" len="sm"/>
-            <a:tailEnd type="none" w="sm" len="sm"/>
-          </a:ln>
-        </p:spPr>
-        <p:txBody>
-          <a:bodyPr spcFirstLastPara="1" wrap="square" lIns="121900" tIns="121900" rIns="121900" bIns="121900" anchor="ctr" anchorCtr="0">
-            <a:noAutofit/>
-          </a:bodyPr>
-          <a:lstStyle/>
-          <a:p>
-            <a:pPr marL="0" marR="0" lvl="0" indent="0" algn="l" rtl="0">
-              <a:lnSpc>
-                <a:spcPct val="100000"/>
-              </a:lnSpc>
-              <a:spcBef>
-                <a:spcPct val="0"/>
-              </a:spcBef>
-              <a:spcAft>
-                <a:spcPct val="0"/>
-              </a:spcAft>
-              <a:buClr>
-                <a:srgbClr val="000000"/>
-              </a:buClr>
-              <a:buSzPts val="1900"/>
-              <a:buFont typeface="Arial"/>
-              <a:buNone/>
-            </a:pPr>
-            <a:r>
-              <a:rPr lang="en-US" sz="1900" b="1" i="0" u="none" strike="noStrike" cap="none">
-                <a:solidFill>
-                  <a:schemeClr val="accent2"/>
-                </a:solidFill>
-                <a:latin typeface="Abel"/>
-                <a:ea typeface="Abel"/>
-                <a:cs typeface="Abel"/>
-                <a:sym typeface="Abel"/>
-              </a:rPr>
-              <a:t>Programación III</a:t>
-            </a:r>
-            <a:endParaRPr sz="1900" b="1" i="0" u="none" strike="noStrike" cap="none">
-              <a:solidFill>
-                <a:schemeClr val="accent2"/>
-              </a:solidFill>
-              <a:latin typeface="Abel"/>
-              <a:ea typeface="Abel"/>
-              <a:cs typeface="Abel"/>
-              <a:sym typeface="Abel"/>
-            </a:endParaRPr>
-          </a:p>
-        </p:txBody>
-      </p:sp>
-      <p:sp>
-        <p:nvSpPr>
-          <p:cNvPr id="410" name="Google Shape;410;g1dc7d2207bd_1_0"/>
-          <p:cNvSpPr/>
-          <p:nvPr/>
-        </p:nvSpPr>
-        <p:spPr>
-          <a:xfrm>
-            <a:off x="3304467" y="5552816"/>
-            <a:ext cx="1922400" cy="545100"/>
-          </a:xfrm>
-          <a:prstGeom prst="homePlate">
-            <a:avLst>
-              <a:gd name="adj" fmla="val 50000"/>
-            </a:avLst>
-          </a:prstGeom>
-          <a:solidFill>
-            <a:schemeClr val="lt2"/>
-          </a:solidFill>
-          <a:ln w="9525" cap="flat" cmpd="sng">
-            <a:solidFill>
-              <a:srgbClr val="3D85C6"/>
-            </a:solidFill>
-            <a:prstDash val="solid"/>
-            <a:round/>
-            <a:headEnd type="none" w="sm" len="sm"/>
-            <a:tailEnd type="none" w="sm" len="sm"/>
-          </a:ln>
-        </p:spPr>
-        <p:txBody>
-          <a:bodyPr spcFirstLastPara="1" wrap="square" lIns="121900" tIns="121900" rIns="121900" bIns="121900" anchor="ctr" anchorCtr="0">
-            <a:noAutofit/>
-          </a:bodyPr>
-          <a:lstStyle/>
-          <a:p>
-            <a:pPr marL="0" marR="0" lvl="0" indent="0" algn="l" rtl="0">
-              <a:lnSpc>
-                <a:spcPct val="100000"/>
-              </a:lnSpc>
-              <a:spcBef>
-                <a:spcPct val="0"/>
-              </a:spcBef>
-              <a:spcAft>
-                <a:spcPct val="0"/>
-              </a:spcAft>
-              <a:buClr>
-                <a:srgbClr val="000000"/>
-              </a:buClr>
-              <a:buSzPts val="1900"/>
-              <a:buFont typeface="Arial"/>
-              <a:buNone/>
-            </a:pPr>
-            <a:r>
-              <a:rPr lang="en-US" sz="1900" b="1" i="0" u="none" strike="noStrike" cap="none">
-                <a:solidFill>
-                  <a:srgbClr val="3D85C6"/>
-                </a:solidFill>
-                <a:latin typeface="Abel"/>
-                <a:ea typeface="Abel"/>
-                <a:cs typeface="Abel"/>
-                <a:sym typeface="Abel"/>
-              </a:rPr>
-              <a:t>Diseño Interfaces</a:t>
-            </a:r>
-            <a:endParaRPr sz="1900" b="1" i="0" u="none" strike="noStrike" cap="none">
-              <a:solidFill>
-                <a:srgbClr val="3D85C6"/>
-              </a:solidFill>
-              <a:latin typeface="Abel"/>
-              <a:ea typeface="Abel"/>
-              <a:cs typeface="Abel"/>
-              <a:sym typeface="Abel"/>
-            </a:endParaRPr>
-          </a:p>
-        </p:txBody>
-      </p:sp>
-      <p:sp>
-        <p:nvSpPr>
-          <p:cNvPr id="411" name="Google Shape;411;g1dc7d2207bd_1_0"/>
-          <p:cNvSpPr/>
-          <p:nvPr/>
-        </p:nvSpPr>
-        <p:spPr>
-          <a:xfrm>
-            <a:off x="7637367" y="4864133"/>
-            <a:ext cx="1922400" cy="545100"/>
-          </a:xfrm>
-          <a:prstGeom prst="homePlate">
-            <a:avLst>
-              <a:gd name="adj" fmla="val 50000"/>
-            </a:avLst>
-          </a:prstGeom>
-          <a:solidFill>
-            <a:schemeClr val="lt2"/>
-          </a:solidFill>
-          <a:ln w="9525" cap="flat" cmpd="sng">
-            <a:solidFill>
-              <a:schemeClr val="accent2"/>
-            </a:solidFill>
-            <a:prstDash val="solid"/>
-            <a:round/>
-            <a:headEnd type="none" w="sm" len="sm"/>
-            <a:tailEnd type="none" w="sm" len="sm"/>
-          </a:ln>
-        </p:spPr>
-        <p:txBody>
-          <a:bodyPr spcFirstLastPara="1" wrap="square" lIns="121900" tIns="121900" rIns="121900" bIns="121900" anchor="ctr" anchorCtr="0">
-            <a:noAutofit/>
-          </a:bodyPr>
-          <a:lstStyle/>
-          <a:p>
-            <a:pPr marL="0" marR="0" lvl="0" indent="0" algn="l" rtl="0">
-              <a:lnSpc>
-                <a:spcPct val="100000"/>
-              </a:lnSpc>
-              <a:spcBef>
-                <a:spcPct val="0"/>
-              </a:spcBef>
-              <a:spcAft>
-                <a:spcPct val="0"/>
-              </a:spcAft>
-              <a:buClr>
-                <a:srgbClr val="000000"/>
-              </a:buClr>
-              <a:buSzPts val="1900"/>
-              <a:buFont typeface="Arial"/>
-              <a:buNone/>
-            </a:pPr>
-            <a:r>
-              <a:rPr lang="en-US" sz="1900" b="1" i="0" u="none" strike="noStrike" cap="none">
-                <a:solidFill>
-                  <a:schemeClr val="accent2"/>
-                </a:solidFill>
-                <a:latin typeface="Abel"/>
-                <a:ea typeface="Abel"/>
-                <a:cs typeface="Abel"/>
-                <a:sym typeface="Abel"/>
-              </a:rPr>
-              <a:t>Programación Concurrente</a:t>
-            </a:r>
-            <a:endParaRPr sz="1900" b="1" i="0" u="none" strike="noStrike" cap="none">
-              <a:solidFill>
-                <a:schemeClr val="accent2"/>
-              </a:solidFill>
-              <a:latin typeface="Abel"/>
-              <a:ea typeface="Abel"/>
-              <a:cs typeface="Abel"/>
-              <a:sym typeface="Abel"/>
-            </a:endParaRPr>
-          </a:p>
-        </p:txBody>
-      </p:sp>
-      <p:sp>
-        <p:nvSpPr>
-          <p:cNvPr id="412" name="Google Shape;412;g1dc7d2207bd_1_0"/>
-          <p:cNvSpPr/>
-          <p:nvPr/>
-        </p:nvSpPr>
-        <p:spPr>
-          <a:xfrm>
-            <a:off x="7637367" y="5521033"/>
-            <a:ext cx="1922400" cy="545100"/>
-          </a:xfrm>
-          <a:prstGeom prst="homePlate">
-            <a:avLst>
-              <a:gd name="adj" fmla="val 50000"/>
-            </a:avLst>
-          </a:prstGeom>
-          <a:solidFill>
-            <a:schemeClr val="lt2"/>
-          </a:solidFill>
-          <a:ln w="9525" cap="flat" cmpd="sng">
-            <a:solidFill>
-              <a:srgbClr val="38761D"/>
-            </a:solidFill>
-            <a:prstDash val="solid"/>
-            <a:round/>
-            <a:headEnd type="none" w="sm" len="sm"/>
-            <a:tailEnd type="none" w="sm" len="sm"/>
-          </a:ln>
-        </p:spPr>
-        <p:txBody>
-          <a:bodyPr spcFirstLastPara="1" wrap="square" lIns="121900" tIns="121900" rIns="121900" bIns="121900" anchor="ctr" anchorCtr="0">
-            <a:noAutofit/>
-          </a:bodyPr>
-          <a:lstStyle/>
-          <a:p>
-            <a:pPr marL="0" marR="0" lvl="0" indent="0" algn="l" rtl="0">
-              <a:lnSpc>
-                <a:spcPct val="100000"/>
-              </a:lnSpc>
-              <a:spcBef>
-                <a:spcPct val="0"/>
-              </a:spcBef>
-              <a:spcAft>
-                <a:spcPct val="0"/>
-              </a:spcAft>
-              <a:buClr>
-                <a:srgbClr val="000000"/>
-              </a:buClr>
-              <a:buSzPts val="1900"/>
-              <a:buFont typeface="Arial"/>
-              <a:buNone/>
-            </a:pPr>
-            <a:r>
-              <a:rPr lang="en-US" sz="1900" b="1" i="0" u="none" strike="noStrike" cap="none">
-                <a:solidFill>
-                  <a:srgbClr val="38761D"/>
-                </a:solidFill>
-                <a:latin typeface="Abel"/>
-                <a:ea typeface="Abel"/>
-                <a:cs typeface="Abel"/>
-                <a:sym typeface="Abel"/>
-              </a:rPr>
-              <a:t>Software I</a:t>
-            </a:r>
-            <a:endParaRPr sz="1900" b="1" i="0" u="none" strike="noStrike" cap="none">
-              <a:solidFill>
-                <a:srgbClr val="38761D"/>
-              </a:solidFill>
-              <a:latin typeface="Abel"/>
-              <a:ea typeface="Abel"/>
-              <a:cs typeface="Abel"/>
-              <a:sym typeface="Abel"/>
-            </a:endParaRPr>
-          </a:p>
-        </p:txBody>
-      </p:sp>
-      <p:sp>
-        <p:nvSpPr>
-          <p:cNvPr id="413" name="Google Shape;413;g1dc7d2207bd_1_0"/>
-          <p:cNvSpPr/>
-          <p:nvPr/>
-        </p:nvSpPr>
-        <p:spPr>
-          <a:xfrm>
-            <a:off x="9689067" y="4864149"/>
-            <a:ext cx="1922400" cy="545100"/>
-          </a:xfrm>
-          <a:prstGeom prst="homePlate">
-            <a:avLst>
-              <a:gd name="adj" fmla="val 50000"/>
-            </a:avLst>
-          </a:prstGeom>
-          <a:solidFill>
-            <a:schemeClr val="lt2"/>
-          </a:solidFill>
-          <a:ln w="9525" cap="flat" cmpd="sng">
-            <a:solidFill>
-              <a:srgbClr val="F6B26B"/>
-            </a:solidFill>
-            <a:prstDash val="solid"/>
-            <a:round/>
-            <a:headEnd type="none" w="sm" len="sm"/>
-            <a:tailEnd type="none" w="sm" len="sm"/>
-          </a:ln>
-        </p:spPr>
-        <p:txBody>
-          <a:bodyPr spcFirstLastPara="1" wrap="square" lIns="121900" tIns="121900" rIns="121900" bIns="121900" anchor="ctr" anchorCtr="0">
-            <a:noAutofit/>
-          </a:bodyPr>
-          <a:lstStyle/>
-          <a:p>
-            <a:pPr marL="0" marR="0" lvl="0" indent="0" algn="l" rtl="0">
-              <a:lnSpc>
-                <a:spcPct val="100000"/>
-              </a:lnSpc>
-              <a:spcBef>
-                <a:spcPct val="0"/>
-              </a:spcBef>
-              <a:spcAft>
-                <a:spcPct val="0"/>
-              </a:spcAft>
-              <a:buClr>
-                <a:srgbClr val="000000"/>
-              </a:buClr>
-              <a:buSzPts val="1900"/>
-              <a:buFont typeface="Arial"/>
-              <a:buNone/>
-            </a:pPr>
-            <a:r>
-              <a:rPr lang="en-US" sz="1900" b="1" i="0" u="none" strike="noStrike" cap="none">
-                <a:solidFill>
-                  <a:srgbClr val="F6B26B"/>
-                </a:solidFill>
-                <a:latin typeface="Abel"/>
-                <a:ea typeface="Abel"/>
-                <a:cs typeface="Abel"/>
-                <a:sym typeface="Abel"/>
-              </a:rPr>
-              <a:t>Sistemas Inteligentes</a:t>
-            </a:r>
-            <a:endParaRPr sz="1900" b="1" i="0" u="none" strike="noStrike" cap="none">
-              <a:solidFill>
-                <a:srgbClr val="F6B26B"/>
-              </a:solidFill>
-              <a:latin typeface="Abel"/>
-              <a:ea typeface="Abel"/>
-              <a:cs typeface="Abel"/>
-              <a:sym typeface="Abel"/>
-            </a:endParaRPr>
-          </a:p>
-        </p:txBody>
-      </p:sp>
-      <p:sp>
-        <p:nvSpPr>
-          <p:cNvPr id="414" name="Google Shape;414;g1dc7d2207bd_1_0"/>
-          <p:cNvSpPr/>
-          <p:nvPr/>
-        </p:nvSpPr>
-        <p:spPr>
-          <a:xfrm>
-            <a:off x="7637367" y="4207233"/>
-            <a:ext cx="1922400" cy="545100"/>
-          </a:xfrm>
-          <a:prstGeom prst="homePlate">
-            <a:avLst>
-              <a:gd name="adj" fmla="val 50000"/>
-            </a:avLst>
-          </a:prstGeom>
-          <a:solidFill>
-            <a:schemeClr val="lt2"/>
-          </a:solidFill>
-          <a:ln w="9525" cap="flat" cmpd="sng">
-            <a:solidFill>
-              <a:srgbClr val="8E7CC3"/>
-            </a:solidFill>
-            <a:prstDash val="solid"/>
-            <a:round/>
-            <a:headEnd type="none" w="sm" len="sm"/>
-            <a:tailEnd type="none" w="sm" len="sm"/>
-          </a:ln>
-        </p:spPr>
-        <p:txBody>
-          <a:bodyPr spcFirstLastPara="1" wrap="square" lIns="121900" tIns="121900" rIns="121900" bIns="121900" anchor="ctr" anchorCtr="0">
-            <a:noAutofit/>
-          </a:bodyPr>
-          <a:lstStyle/>
-          <a:p>
-            <a:pPr marL="0" marR="0" lvl="0" indent="0" algn="l" rtl="0">
-              <a:lnSpc>
-                <a:spcPct val="100000"/>
-              </a:lnSpc>
-              <a:spcBef>
-                <a:spcPct val="0"/>
-              </a:spcBef>
-              <a:spcAft>
-                <a:spcPct val="0"/>
-              </a:spcAft>
-              <a:buClr>
-                <a:srgbClr val="000000"/>
-              </a:buClr>
-              <a:buSzPts val="1900"/>
-              <a:buFont typeface="Arial"/>
-              <a:buNone/>
-            </a:pPr>
-            <a:r>
-              <a:rPr lang="en-US" sz="1900" b="1" i="0" u="none" strike="noStrike" cap="none">
-                <a:solidFill>
-                  <a:srgbClr val="674EA7"/>
-                </a:solidFill>
-                <a:latin typeface="Abel"/>
-                <a:ea typeface="Abel"/>
-                <a:cs typeface="Abel"/>
-                <a:sym typeface="Abel"/>
-              </a:rPr>
-              <a:t>Estructuras de Datos</a:t>
-            </a:r>
-            <a:endParaRPr sz="1900" b="1" i="0" u="none" strike="noStrike" cap="none">
-              <a:solidFill>
-                <a:srgbClr val="674EA7"/>
-              </a:solidFill>
-              <a:latin typeface="Abel"/>
-              <a:ea typeface="Abel"/>
-              <a:cs typeface="Abel"/>
-              <a:sym typeface="Abel"/>
-            </a:endParaRPr>
-          </a:p>
-        </p:txBody>
-      </p:sp>
-      <p:sp>
-        <p:nvSpPr>
-          <p:cNvPr id="415" name="Google Shape;415;g1dc7d2207bd_1_0"/>
-          <p:cNvSpPr/>
-          <p:nvPr/>
-        </p:nvSpPr>
-        <p:spPr>
-          <a:xfrm>
-            <a:off x="9689067" y="4207233"/>
-            <a:ext cx="1922400" cy="545100"/>
-          </a:xfrm>
-          <a:prstGeom prst="homePlate">
-            <a:avLst>
-              <a:gd name="adj" fmla="val 50000"/>
-            </a:avLst>
-          </a:prstGeom>
-          <a:solidFill>
-            <a:schemeClr val="lt2"/>
-          </a:solidFill>
-          <a:ln w="9525" cap="flat" cmpd="sng">
-            <a:solidFill>
-              <a:srgbClr val="A64D79"/>
-            </a:solidFill>
-            <a:prstDash val="solid"/>
-            <a:round/>
-            <a:headEnd type="none" w="sm" len="sm"/>
-            <a:tailEnd type="none" w="sm" len="sm"/>
-          </a:ln>
-        </p:spPr>
-        <p:txBody>
-          <a:bodyPr spcFirstLastPara="1" wrap="square" lIns="121900" tIns="121900" rIns="121900" bIns="121900" anchor="ctr" anchorCtr="0">
-            <a:noAutofit/>
-          </a:bodyPr>
-          <a:lstStyle/>
-          <a:p>
-            <a:pPr marL="0" marR="0" lvl="0" indent="0" algn="l" rtl="0">
-              <a:lnSpc>
-                <a:spcPct val="100000"/>
-              </a:lnSpc>
-              <a:spcBef>
-                <a:spcPct val="0"/>
-              </a:spcBef>
-              <a:spcAft>
-                <a:spcPct val="0"/>
-              </a:spcAft>
-              <a:buClr>
-                <a:srgbClr val="000000"/>
-              </a:buClr>
-              <a:buSzPts val="1900"/>
-              <a:buFont typeface="Arial"/>
-              <a:buNone/>
-            </a:pPr>
-            <a:r>
-              <a:rPr lang="en-US" sz="1900" b="1" i="0" u="none" strike="noStrike" cap="none" dirty="0">
-                <a:solidFill>
-                  <a:srgbClr val="A64D79"/>
-                </a:solidFill>
-                <a:latin typeface="Abel"/>
-                <a:ea typeface="Abel"/>
-                <a:cs typeface="Abel"/>
-                <a:sym typeface="Abel"/>
-              </a:rPr>
-              <a:t>Bases de </a:t>
-            </a:r>
-            <a:br>
-              <a:rPr lang="en-US" sz="1900" b="1" i="0" u="none" strike="noStrike" cap="none" dirty="0">
-                <a:solidFill>
-                  <a:srgbClr val="A64D79"/>
-                </a:solidFill>
-                <a:latin typeface="Abel"/>
-                <a:ea typeface="Abel"/>
-                <a:cs typeface="Abel"/>
-                <a:sym typeface="Abel"/>
-              </a:rPr>
-            </a:br>
-            <a:r>
-              <a:rPr lang="en-US" sz="1900" b="1" i="0" u="none" strike="noStrike" cap="none" dirty="0" err="1">
-                <a:solidFill>
-                  <a:srgbClr val="A64D79"/>
-                </a:solidFill>
-                <a:latin typeface="Abel"/>
-                <a:ea typeface="Abel"/>
-                <a:cs typeface="Abel"/>
-                <a:sym typeface="Abel"/>
-              </a:rPr>
-              <a:t>Datos</a:t>
-            </a:r>
-            <a:r>
-              <a:rPr lang="en-US" sz="1900" b="1" i="0" u="none" strike="noStrike" cap="none" dirty="0">
-                <a:solidFill>
-                  <a:srgbClr val="A64D79"/>
-                </a:solidFill>
-                <a:latin typeface="Abel"/>
-                <a:ea typeface="Abel"/>
-                <a:cs typeface="Abel"/>
-                <a:sym typeface="Abel"/>
-              </a:rPr>
-              <a:t> I</a:t>
-            </a:r>
-            <a:endParaRPr sz="1900" b="1" i="0" u="none" strike="noStrike" cap="none" dirty="0">
-              <a:solidFill>
-                <a:srgbClr val="A64D79"/>
-              </a:solidFill>
-              <a:latin typeface="Abel"/>
-              <a:ea typeface="Abel"/>
-              <a:cs typeface="Abel"/>
-              <a:sym typeface="Abel"/>
-            </a:endParaRPr>
-          </a:p>
-        </p:txBody>
-      </p:sp>
-      <p:sp>
-        <p:nvSpPr>
           <p:cNvPr id="416" name="Google Shape;416;g1dc7d2207bd_1_0"/>
           <p:cNvSpPr txBox="1"/>
           <p:nvPr/>
@@ -6406,7 +5582,7 @@
         <p:spPr>
           <a:xfrm>
             <a:off x="1017725" y="1554525"/>
-            <a:ext cx="8949900" cy="461700"/>
+            <a:ext cx="8949900" cy="503184"/>
           </a:xfrm>
           <a:prstGeom prst="rect">
             <a:avLst/>
@@ -6440,7 +5616,7 @@
               <a:buNone/>
             </a:pPr>
             <a:r>
-              <a:rPr lang="en-US" sz="1800" b="0" i="0" u="none" strike="noStrike" cap="none">
+              <a:rPr lang="en-US" sz="1800" b="0" i="0" u="none" strike="noStrike" cap="none" dirty="0">
                 <a:solidFill>
                   <a:schemeClr val="dk1"/>
                 </a:solidFill>
@@ -6449,9 +5625,81 @@
                 <a:cs typeface="Trebuchet MS"/>
                 <a:sym typeface="Trebuchet MS"/>
               </a:rPr>
-              <a:t>Plan de estudios Ingeniería de Sistemas y Computación</a:t>
-            </a:r>
-            <a:endParaRPr sz="1400" b="0" i="0" u="none" strike="noStrike" cap="none">
+              <a:t>Plan de </a:t>
+            </a:r>
+            <a:r>
+              <a:rPr lang="en-US" sz="1800" b="0" i="0" u="none" strike="noStrike" cap="none" dirty="0" err="1">
+                <a:solidFill>
+                  <a:schemeClr val="dk1"/>
+                </a:solidFill>
+                <a:latin typeface="Trebuchet MS"/>
+                <a:ea typeface="Trebuchet MS"/>
+                <a:cs typeface="Trebuchet MS"/>
+                <a:sym typeface="Trebuchet MS"/>
+              </a:rPr>
+              <a:t>estudios</a:t>
+            </a:r>
+            <a:r>
+              <a:rPr lang="en-US" sz="1800" b="0" i="0" u="none" strike="noStrike" cap="none" dirty="0">
+                <a:solidFill>
+                  <a:schemeClr val="dk1"/>
+                </a:solidFill>
+                <a:latin typeface="Trebuchet MS"/>
+                <a:ea typeface="Trebuchet MS"/>
+                <a:cs typeface="Trebuchet MS"/>
+                <a:sym typeface="Trebuchet MS"/>
+              </a:rPr>
+              <a:t> </a:t>
+            </a:r>
+            <a:r>
+              <a:rPr lang="en-US" sz="1800" b="0" i="0" u="none" strike="noStrike" cap="none" dirty="0" err="1">
+                <a:solidFill>
+                  <a:schemeClr val="dk1"/>
+                </a:solidFill>
+                <a:latin typeface="Trebuchet MS"/>
+                <a:ea typeface="Trebuchet MS"/>
+                <a:cs typeface="Trebuchet MS"/>
+                <a:sym typeface="Trebuchet MS"/>
+              </a:rPr>
+              <a:t>Profesional</a:t>
+            </a:r>
+            <a:r>
+              <a:rPr lang="en-US" sz="1800" b="0" i="0" u="none" strike="noStrike" cap="none" dirty="0">
+                <a:solidFill>
+                  <a:schemeClr val="dk1"/>
+                </a:solidFill>
+                <a:latin typeface="Trebuchet MS"/>
+                <a:ea typeface="Trebuchet MS"/>
+                <a:cs typeface="Trebuchet MS"/>
+                <a:sym typeface="Trebuchet MS"/>
+              </a:rPr>
+              <a:t> </a:t>
+            </a:r>
+            <a:r>
+              <a:rPr lang="en-US" sz="1800" b="0" i="0" u="none" strike="noStrike" cap="none" dirty="0" err="1">
+                <a:solidFill>
+                  <a:schemeClr val="dk1"/>
+                </a:solidFill>
+                <a:latin typeface="Trebuchet MS"/>
+                <a:ea typeface="Trebuchet MS"/>
+                <a:cs typeface="Trebuchet MS"/>
+                <a:sym typeface="Trebuchet MS"/>
+              </a:rPr>
+              <a:t>en</a:t>
+            </a:r>
+            <a:r>
+              <a:rPr lang="en-US" sz="1800" b="0" i="0" u="none" strike="noStrike" cap="none" dirty="0">
+                <a:solidFill>
+                  <a:schemeClr val="dk1"/>
+                </a:solidFill>
+                <a:latin typeface="Trebuchet MS"/>
+                <a:ea typeface="Trebuchet MS"/>
+                <a:cs typeface="Trebuchet MS"/>
+                <a:sym typeface="Trebuchet MS"/>
+              </a:rPr>
+              <a:t> Ciencia de Datos</a:t>
+            </a:r>
+            <a:endParaRPr sz="1400" b="0" i="0" u="none" strike="noStrike" cap="none" dirty="0">
               <a:solidFill>
                 <a:srgbClr val="000000"/>
               </a:solidFill>
@@ -6463,72 +5711,36 @@
           </a:p>
         </p:txBody>
       </p:sp>
-      <p:sp>
-        <p:nvSpPr>
-          <p:cNvPr id="417" name="Google Shape;417;g1dc7d2207bd_1_0"/>
-          <p:cNvSpPr txBox="1"/>
+      <p:pic>
+        <p:nvPicPr>
+          <p:cNvPr id="3" name="Imagen 2">
+            <a:extLst>
+              <a:ext uri="{FF2B5EF4-FFF2-40B4-BE49-F238E27FC236}">
+                <a16:creationId xmlns:a16="http://schemas.microsoft.com/office/drawing/2014/main" id="{A5401088-EB55-64CB-0B36-62AB93D1FFE4}"/>
+              </a:ext>
+            </a:extLst>
+          </p:cNvPr>
+          <p:cNvPicPr>
+            <a:picLocks noChangeAspect="1"/>
+          </p:cNvPicPr>
           <p:nvPr/>
-        </p:nvSpPr>
+        </p:nvPicPr>
+        <p:blipFill>
+          <a:blip r:embed="rId4"/>
+          <a:stretch>
+            <a:fillRect/>
+          </a:stretch>
+        </p:blipFill>
         <p:spPr>
           <a:xfrm>
-            <a:off x="1013713" y="6259466"/>
-            <a:ext cx="7411196" cy="446400"/>
+            <a:off x="827939" y="2017204"/>
+            <a:ext cx="7772400" cy="4667321"/>
           </a:xfrm>
           <a:prstGeom prst="rect">
             <a:avLst/>
           </a:prstGeom>
-          <a:noFill/>
-          <a:ln>
-            <a:noFill/>
-          </a:ln>
         </p:spPr>
-        <p:txBody>
-          <a:bodyPr spcFirstLastPara="1" wrap="square" lIns="121900" tIns="121900" rIns="121900" bIns="121900" anchor="t" anchorCtr="0">
-            <a:spAutoFit/>
-          </a:bodyPr>
-          <a:lstStyle/>
-          <a:p>
-            <a:pPr marL="0" marR="0" lvl="0" indent="0" algn="l" rtl="0">
-              <a:lnSpc>
-                <a:spcPct val="100000"/>
-              </a:lnSpc>
-              <a:spcBef>
-                <a:spcPct val="0"/>
-              </a:spcBef>
-              <a:spcAft>
-                <a:spcPct val="0"/>
-              </a:spcAft>
-              <a:buClr>
-                <a:srgbClr val="000000"/>
-              </a:buClr>
-              <a:buSzPts val="1300"/>
-              <a:buFont typeface="Arial"/>
-              <a:buNone/>
-            </a:pPr>
-            <a:r>
-              <a:rPr lang="en-US" sz="1300" b="0" i="0" u="none" strike="noStrike" cap="none" dirty="0">
-                <a:solidFill>
-                  <a:srgbClr val="000000"/>
-                </a:solidFill>
-                <a:latin typeface="Trebuchet MS"/>
-                <a:ea typeface="Trebuchet MS"/>
-                <a:cs typeface="Trebuchet MS"/>
-                <a:sym typeface="Trebuchet MS"/>
-              </a:rPr>
-              <a:t>http://acad.ucaldas.edu.co/gestionacademica/planestudios/pensumver.asp?cod_carrera=170</a:t>
-            </a:r>
-            <a:endParaRPr sz="1300" b="0" i="0" u="none" strike="noStrike" cap="none" dirty="0">
-              <a:solidFill>
-                <a:srgbClr val="000000"/>
-              </a:solidFill>
-              <a:latin typeface="Trebuchet MS"/>
-              <a:ea typeface="Trebuchet MS"/>
-              <a:cs typeface="Trebuchet MS"/>
-              <a:sym typeface="Trebuchet MS"/>
-            </a:endParaRPr>
-          </a:p>
-        </p:txBody>
-      </p:sp>
+      </p:pic>
     </p:spTree>
   </p:cSld>
   <p:clrMapOvr>

</xml_diff>